<commit_message>
Slides: Judge slide compares Jev ($0.02 once) with LLM list prices for reading BGL (Haiku ≈ $89, Sonnet ≈ $354, Opus ≈ $708); script + sources updated
Co-Authored-By: Claude Opus 5.5 <noreply@anthropic.com>
</commit_message>
<xml_diff>
--- a/docs/slides/making-sense-of-logs.pptx
+++ b/docs/slides/making-sense-of-logs.pptx
@@ -1538,7 +1538,7 @@
             <a:r>
               <a:rPr lang="en-US" dirty="0"/>
               <a:t>1:15 · 5 · Judge
-"Step two is where it gets cheap. Jev, a small typed-judgment model, runs inside SereneDB and asks each kind of message once: is it a real fault or a routine dump? an attack? whose is it? 1,126 kinds of message in 20 seconds for 2 cents, stored. Reading BGL with a large model would be about 177 million tokens, every time. And it works: real alerts in the manager's top 10 go from 1 to 5."</a:t>
+"Step two is where it gets cheap. Jev, a small typed-judgment model, runs inside SereneDB and asks each kind of message once: is it a real fault or a routine dump? an attack? whose is it? 1,126 kinds of message in 20 seconds for 2 cents, stored. Having an LLM read BGL instead is about 177 million tokens: roughly 89 dollars on Haiku, 354 on Sonnet, 708 on Opus, and again for every question. And it works: real alerts in the manager's top 10 go from 1 to 5."</a:t>
             </a:r>
             <a:endParaRPr lang="en-US" dirty="0"/>
           </a:p>
@@ -10822,122 +10822,43 @@
             </a:r>
             <a:endParaRPr lang="en-US" sz="1350" dirty="0"/>
           </a:p>
-        </p:txBody>
-      </p:sp>
-      <p:sp>
-        <p:nvSpPr>
-          <p:cNvPr id="24" name="Shape 16"/>
+          <a:p>
+            <a:pPr marL="177800" indent="-177800">
+              <a:spcAft>
+                <a:spcPts val="800"/>
+              </a:spcAft>
+              <a:buSzPct val="100000"/>
+              <a:buChar char="•"/>
+            </a:pPr>
+            <a:r>
+              <a:rPr lang="en-US" sz="1350" dirty="0">
+                <a:solidFill>
+                  <a:srgbClr val="3A3F55"/>
+                </a:solidFill>
+                <a:latin typeface="Avenir Next" pitchFamily="34" charset="0"/>
+                <a:ea typeface="Avenir Next" pitchFamily="34" charset="-122"/>
+                <a:cs typeface="Avenir Next" pitchFamily="34" charset="-120"/>
+              </a:rPr>
+              <a:t>Real alerts in the manager's top 10: 1 → 5</a:t>
+            </a:r>
+            <a:endParaRPr lang="en-US" sz="1350" dirty="0"/>
+          </a:p>
+        </p:txBody>
+      </p:sp>
+      <p:sp>
+        <p:nvSpPr>
+          <p:cNvPr id="25" name="Shape 16"/>
           <p:cNvSpPr/>
           <p:nvPr/>
         </p:nvSpPr>
         <p:spPr>
           <a:xfrm>
             <a:off x="4663440" y="1874520"/>
-            <a:ext cx="4023360" cy="774192"/>
+            <a:ext cx="4023360" cy="2651760"/>
           </a:xfrm>
           <a:prstGeom prst="roundRect">
             <a:avLst>
-              <a:gd name="adj" fmla="val 16535"/>
-            </a:avLst>
-          </a:prstGeom>
-          <a:solidFill>
-            <a:srgbClr val="F1ECFD"/>
-          </a:solidFill>
-          <a:ln/>
-        </p:spPr>
-      </p:sp>
-      <p:sp>
-        <p:nvSpPr>
-          <p:cNvPr id="25" name="Text 17"/>
-          <p:cNvSpPr/>
-          <p:nvPr/>
-        </p:nvSpPr>
-        <p:spPr>
-          <a:xfrm>
-            <a:off x="4892040" y="1947672"/>
-            <a:ext cx="3611880" cy="425806"/>
-          </a:xfrm>
-          <a:prstGeom prst="rect">
-            <a:avLst/>
-          </a:prstGeom>
-          <a:noFill/>
-          <a:ln/>
-        </p:spPr>
-        <p:txBody>
-          <a:bodyPr wrap="square" lIns="0" tIns="0" rIns="0" bIns="0" rtlCol="0" anchor="b"/>
-          <a:lstStyle/>
-          <a:p>
-            <a:pPr indent="0" marL="0">
-              <a:buNone/>
-            </a:pPr>
-            <a:r>
-              <a:rPr lang="en-US" sz="2400" b="1" dirty="0">
-                <a:solidFill>
-                  <a:srgbClr val="6A4BD8"/>
-                </a:solidFill>
-                <a:latin typeface="Avenir Next" pitchFamily="34" charset="0"/>
-                <a:ea typeface="Avenir Next" pitchFamily="34" charset="-122"/>
-                <a:cs typeface="Avenir Next" pitchFamily="34" charset="-120"/>
-              </a:rPr>
-              <a:t>$0.02 · 20 s</a:t>
-            </a:r>
-            <a:endParaRPr lang="en-US" sz="2400" dirty="0"/>
-          </a:p>
-        </p:txBody>
-      </p:sp>
-      <p:sp>
-        <p:nvSpPr>
-          <p:cNvPr id="26" name="Text 18"/>
-          <p:cNvSpPr/>
-          <p:nvPr/>
-        </p:nvSpPr>
-        <p:spPr>
-          <a:xfrm>
-            <a:off x="4892040" y="2339035"/>
-            <a:ext cx="3611880" cy="294193"/>
-          </a:xfrm>
-          <a:prstGeom prst="rect">
-            <a:avLst/>
-          </a:prstGeom>
-          <a:noFill/>
-          <a:ln/>
-        </p:spPr>
-        <p:txBody>
-          <a:bodyPr wrap="square" lIns="0" tIns="0" rIns="0" bIns="0" rtlCol="0" anchor="t"/>
-          <a:lstStyle/>
-          <a:p>
-            <a:pPr indent="0" marL="0">
-              <a:buNone/>
-            </a:pPr>
-            <a:r>
-              <a:rPr lang="en-US" sz="1150" dirty="0">
-                <a:solidFill>
-                  <a:srgbClr val="3A3F55"/>
-                </a:solidFill>
-                <a:latin typeface="Avenir Next" pitchFamily="34" charset="0"/>
-                <a:ea typeface="Avenir Next" pitchFamily="34" charset="-122"/>
-                <a:cs typeface="Avenir Next" pitchFamily="34" charset="-120"/>
-              </a:rPr>
-              <a:t>Jev judges all 1,126 BGL kinds of message</a:t>
-            </a:r>
-            <a:endParaRPr lang="en-US" sz="1150" dirty="0"/>
-          </a:p>
-        </p:txBody>
-      </p:sp>
-      <p:sp>
-        <p:nvSpPr>
-          <p:cNvPr id="27" name="Shape 19"/>
-          <p:cNvSpPr/>
-          <p:nvPr/>
-        </p:nvSpPr>
-        <p:spPr>
-          <a:xfrm>
-            <a:off x="4663440" y="2758440"/>
-            <a:ext cx="4023360" cy="774192"/>
-          </a:xfrm>
-          <a:prstGeom prst="roundRect">
-            <a:avLst>
-              <a:gd name="adj" fmla="val 16535"/>
+              <a:gd name="adj" fmla="val 4828"/>
             </a:avLst>
           </a:prstGeom>
           <a:solidFill>
@@ -10953,135 +10874,130 @@
       </p:sp>
       <p:sp>
         <p:nvSpPr>
-          <p:cNvPr id="28" name="Text 20"/>
-          <p:cNvSpPr/>
-          <p:nvPr/>
-        </p:nvSpPr>
-        <p:spPr>
-          <a:xfrm>
-            <a:off x="4892040" y="2831592"/>
-            <a:ext cx="3611880" cy="425806"/>
-          </a:xfrm>
-          <a:prstGeom prst="rect">
-            <a:avLst/>
-          </a:prstGeom>
-          <a:noFill/>
-          <a:ln/>
-        </p:spPr>
-        <p:txBody>
-          <a:bodyPr wrap="square" lIns="0" tIns="0" rIns="0" bIns="0" rtlCol="0" anchor="b"/>
-          <a:lstStyle/>
-          <a:p>
-            <a:pPr indent="0" marL="0">
-              <a:buNone/>
-            </a:pPr>
-            <a:r>
-              <a:rPr lang="en-US" sz="2400" b="1" dirty="0">
-                <a:solidFill>
-                  <a:srgbClr val="6A4BD8"/>
-                </a:solidFill>
-                <a:latin typeface="Avenir Next" pitchFamily="34" charset="0"/>
-                <a:ea typeface="Avenir Next" pitchFamily="34" charset="-122"/>
-                <a:cs typeface="Avenir Next" pitchFamily="34" charset="-120"/>
-              </a:rPr>
-              <a:t>≈ 177 M tokens</a:t>
-            </a:r>
-            <a:endParaRPr lang="en-US" sz="2400" dirty="0"/>
-          </a:p>
-        </p:txBody>
-      </p:sp>
-      <p:sp>
-        <p:nvSpPr>
-          <p:cNvPr id="29" name="Text 21"/>
-          <p:cNvSpPr/>
-          <p:nvPr/>
-        </p:nvSpPr>
-        <p:spPr>
-          <a:xfrm>
-            <a:off x="4892040" y="3222955"/>
-            <a:ext cx="3611880" cy="294193"/>
-          </a:xfrm>
-          <a:prstGeom prst="rect">
-            <a:avLst/>
-          </a:prstGeom>
-          <a:noFill/>
-          <a:ln/>
-        </p:spPr>
-        <p:txBody>
-          <a:bodyPr wrap="square" lIns="0" tIns="0" rIns="0" bIns="0" rtlCol="0" anchor="t"/>
-          <a:lstStyle/>
-          <a:p>
-            <a:pPr indent="0" marL="0">
-              <a:buNone/>
-            </a:pPr>
-            <a:r>
-              <a:rPr lang="en-US" sz="1150" dirty="0">
-                <a:solidFill>
-                  <a:srgbClr val="3A3F55"/>
-                </a:solidFill>
-                <a:latin typeface="Avenir Next" pitchFamily="34" charset="0"/>
-                <a:ea typeface="Avenir Next" pitchFamily="34" charset="-122"/>
-                <a:cs typeface="Avenir Next" pitchFamily="34" charset="-120"/>
-              </a:rPr>
-              <a:t>for an LLM to read BGL once (estimate), every time</a:t>
-            </a:r>
-            <a:endParaRPr lang="en-US" sz="1150" dirty="0"/>
-          </a:p>
-        </p:txBody>
-      </p:sp>
-      <p:sp>
-        <p:nvSpPr>
-          <p:cNvPr id="30" name="Shape 22"/>
-          <p:cNvSpPr/>
-          <p:nvPr/>
-        </p:nvSpPr>
-        <p:spPr>
-          <a:xfrm>
-            <a:off x="4663440" y="3642360"/>
-            <a:ext cx="4023360" cy="774192"/>
+          <p:cNvPr id="26" name="Text 17"/>
+          <p:cNvSpPr/>
+          <p:nvPr/>
+        </p:nvSpPr>
+        <p:spPr>
+          <a:xfrm>
+            <a:off x="4892040" y="1965960"/>
+            <a:ext cx="3611880" cy="292608"/>
+          </a:xfrm>
+          <a:prstGeom prst="rect">
+            <a:avLst/>
+          </a:prstGeom>
+          <a:noFill/>
+          <a:ln/>
+        </p:spPr>
+        <p:txBody>
+          <a:bodyPr wrap="square" lIns="0" tIns="0" rIns="0" bIns="0" rtlCol="0" anchor="ctr"/>
+          <a:lstStyle/>
+          <a:p>
+            <a:pPr indent="0" marL="0">
+              <a:buNone/>
+            </a:pPr>
+            <a:r>
+              <a:rPr lang="en-US" sz="1250" b="1" dirty="0">
+                <a:solidFill>
+                  <a:srgbClr val="11121D"/>
+                </a:solidFill>
+                <a:latin typeface="Avenir Next" pitchFamily="34" charset="0"/>
+                <a:ea typeface="Avenir Next" pitchFamily="34" charset="-122"/>
+                <a:cs typeface="Avenir Next" pitchFamily="34" charset="-120"/>
+              </a:rPr>
+              <a:t>Cost to judge BGL once</a:t>
+            </a:r>
+            <a:endParaRPr lang="en-US" sz="1250" dirty="0"/>
+          </a:p>
+        </p:txBody>
+      </p:sp>
+      <p:sp>
+        <p:nvSpPr>
+          <p:cNvPr id="27" name="Shape 18"/>
+          <p:cNvSpPr/>
+          <p:nvPr/>
+        </p:nvSpPr>
+        <p:spPr>
+          <a:xfrm>
+            <a:off x="4800600" y="2295144"/>
+            <a:ext cx="3749040" cy="420624"/>
           </a:xfrm>
           <a:prstGeom prst="roundRect">
             <a:avLst>
-              <a:gd name="adj" fmla="val 16535"/>
+              <a:gd name="adj" fmla="val 21739"/>
             </a:avLst>
           </a:prstGeom>
           <a:solidFill>
-            <a:srgbClr val="FFFFFF"/>
+            <a:srgbClr val="F1ECFD"/>
           </a:solidFill>
-          <a:ln w="12700">
-            <a:solidFill>
-              <a:srgbClr val="E3E6EC"/>
-            </a:solidFill>
-            <a:prstDash val="solid"/>
-          </a:ln>
-        </p:spPr>
-      </p:sp>
-      <p:sp>
-        <p:nvSpPr>
-          <p:cNvPr id="31" name="Text 23"/>
-          <p:cNvSpPr/>
-          <p:nvPr/>
-        </p:nvSpPr>
-        <p:spPr>
-          <a:xfrm>
-            <a:off x="4892040" y="3715512"/>
-            <a:ext cx="3611880" cy="425806"/>
-          </a:xfrm>
-          <a:prstGeom prst="rect">
-            <a:avLst/>
-          </a:prstGeom>
-          <a:noFill/>
-          <a:ln/>
-        </p:spPr>
-        <p:txBody>
-          <a:bodyPr wrap="square" lIns="0" tIns="0" rIns="0" bIns="0" rtlCol="0" anchor="b"/>
-          <a:lstStyle/>
-          <a:p>
-            <a:pPr indent="0" marL="0">
-              <a:buNone/>
-            </a:pPr>
-            <a:r>
-              <a:rPr lang="en-US" sz="2400" b="1" dirty="0">
+          <a:ln/>
+        </p:spPr>
+      </p:sp>
+      <p:sp>
+        <p:nvSpPr>
+          <p:cNvPr id="28" name="Text 19"/>
+          <p:cNvSpPr/>
+          <p:nvPr/>
+        </p:nvSpPr>
+        <p:spPr>
+          <a:xfrm>
+            <a:off x="4937760" y="2331720"/>
+            <a:ext cx="2514600" cy="347472"/>
+          </a:xfrm>
+          <a:prstGeom prst="rect">
+            <a:avLst/>
+          </a:prstGeom>
+          <a:noFill/>
+          <a:ln/>
+        </p:spPr>
+        <p:txBody>
+          <a:bodyPr wrap="square" lIns="0" tIns="0" rIns="0" bIns="0" rtlCol="0" anchor="ctr"/>
+          <a:lstStyle/>
+          <a:p>
+            <a:pPr indent="0" marL="0">
+              <a:buNone/>
+            </a:pPr>
+            <a:r>
+              <a:rPr lang="en-US" sz="1150" b="1" dirty="0">
+                <a:solidFill>
+                  <a:srgbClr val="3A3F55"/>
+                </a:solidFill>
+                <a:latin typeface="Avenir Next" pitchFamily="34" charset="0"/>
+                <a:ea typeface="Avenir Next" pitchFamily="34" charset="-122"/>
+                <a:cs typeface="Avenir Next" pitchFamily="34" charset="-120"/>
+              </a:rPr>
+              <a:t>Jev, once per kind of message</a:t>
+            </a:r>
+            <a:endParaRPr lang="en-US" sz="1150" dirty="0"/>
+          </a:p>
+        </p:txBody>
+      </p:sp>
+      <p:sp>
+        <p:nvSpPr>
+          <p:cNvPr id="29" name="Text 20"/>
+          <p:cNvSpPr/>
+          <p:nvPr/>
+        </p:nvSpPr>
+        <p:spPr>
+          <a:xfrm>
+            <a:off x="7406640" y="2331720"/>
+            <a:ext cx="1097280" cy="347472"/>
+          </a:xfrm>
+          <a:prstGeom prst="rect">
+            <a:avLst/>
+          </a:prstGeom>
+          <a:noFill/>
+          <a:ln/>
+        </p:spPr>
+        <p:txBody>
+          <a:bodyPr wrap="square" lIns="0" tIns="0" rIns="0" bIns="0" rtlCol="0" anchor="ctr"/>
+          <a:lstStyle/>
+          <a:p>
+            <a:pPr algn="r" indent="0" marL="0">
+              <a:buNone/>
+            </a:pPr>
+            <a:r>
+              <a:rPr lang="en-US" sz="1600" b="1" dirty="0">
                 <a:solidFill>
                   <a:srgbClr val="6A4BD8"/>
                 </a:solidFill>
@@ -11089,22 +11005,256 @@
                 <a:ea typeface="Avenir Next" pitchFamily="34" charset="-122"/>
                 <a:cs typeface="Avenir Next" pitchFamily="34" charset="-120"/>
               </a:rPr>
-              <a:t>1 → 5</a:t>
-            </a:r>
-            <a:endParaRPr lang="en-US" sz="2400" dirty="0"/>
-          </a:p>
-        </p:txBody>
-      </p:sp>
-      <p:sp>
-        <p:nvSpPr>
-          <p:cNvPr id="32" name="Text 24"/>
-          <p:cNvSpPr/>
-          <p:nvPr/>
-        </p:nvSpPr>
-        <p:spPr>
-          <a:xfrm>
-            <a:off x="4892040" y="4106875"/>
-            <a:ext cx="3611880" cy="294193"/>
+              <a:t>$0.02</a:t>
+            </a:r>
+            <a:endParaRPr lang="en-US" sz="1600" dirty="0"/>
+          </a:p>
+        </p:txBody>
+      </p:sp>
+      <p:sp>
+        <p:nvSpPr>
+          <p:cNvPr id="30" name="Text 21"/>
+          <p:cNvSpPr/>
+          <p:nvPr/>
+        </p:nvSpPr>
+        <p:spPr>
+          <a:xfrm>
+            <a:off x="4937760" y="2788920"/>
+            <a:ext cx="2514600" cy="347472"/>
+          </a:xfrm>
+          <a:prstGeom prst="rect">
+            <a:avLst/>
+          </a:prstGeom>
+          <a:noFill/>
+          <a:ln/>
+        </p:spPr>
+        <p:txBody>
+          <a:bodyPr wrap="square" lIns="0" tIns="0" rIns="0" bIns="0" rtlCol="0" anchor="ctr"/>
+          <a:lstStyle/>
+          <a:p>
+            <a:pPr indent="0" marL="0">
+              <a:buNone/>
+            </a:pPr>
+            <a:r>
+              <a:rPr lang="en-US" sz="1150" dirty="0">
+                <a:solidFill>
+                  <a:srgbClr val="3A3F55"/>
+                </a:solidFill>
+                <a:latin typeface="Avenir Next" pitchFamily="34" charset="0"/>
+                <a:ea typeface="Avenir Next" pitchFamily="34" charset="-122"/>
+                <a:cs typeface="Avenir Next" pitchFamily="34" charset="-120"/>
+              </a:rPr>
+              <a:t>Haiku 5.5 reads every line</a:t>
+            </a:r>
+            <a:endParaRPr lang="en-US" sz="1150" dirty="0"/>
+          </a:p>
+        </p:txBody>
+      </p:sp>
+      <p:sp>
+        <p:nvSpPr>
+          <p:cNvPr id="31" name="Text 22"/>
+          <p:cNvSpPr/>
+          <p:nvPr/>
+        </p:nvSpPr>
+        <p:spPr>
+          <a:xfrm>
+            <a:off x="7406640" y="2788920"/>
+            <a:ext cx="1097280" cy="347472"/>
+          </a:xfrm>
+          <a:prstGeom prst="rect">
+            <a:avLst/>
+          </a:prstGeom>
+          <a:noFill/>
+          <a:ln/>
+        </p:spPr>
+        <p:txBody>
+          <a:bodyPr wrap="square" lIns="0" tIns="0" rIns="0" bIns="0" rtlCol="0" anchor="ctr"/>
+          <a:lstStyle/>
+          <a:p>
+            <a:pPr algn="r" indent="0" marL="0">
+              <a:buNone/>
+            </a:pPr>
+            <a:r>
+              <a:rPr lang="en-US" sz="1600" b="1" dirty="0">
+                <a:solidFill>
+                  <a:srgbClr val="C2410C"/>
+                </a:solidFill>
+                <a:latin typeface="Avenir Next" pitchFamily="34" charset="0"/>
+                <a:ea typeface="Avenir Next" pitchFamily="34" charset="-122"/>
+                <a:cs typeface="Avenir Next" pitchFamily="34" charset="-120"/>
+              </a:rPr>
+              <a:t>≈ $89</a:t>
+            </a:r>
+            <a:endParaRPr lang="en-US" sz="1600" dirty="0"/>
+          </a:p>
+        </p:txBody>
+      </p:sp>
+      <p:sp>
+        <p:nvSpPr>
+          <p:cNvPr id="32" name="Text 23"/>
+          <p:cNvSpPr/>
+          <p:nvPr/>
+        </p:nvSpPr>
+        <p:spPr>
+          <a:xfrm>
+            <a:off x="4937760" y="3246120"/>
+            <a:ext cx="2514600" cy="347472"/>
+          </a:xfrm>
+          <a:prstGeom prst="rect">
+            <a:avLst/>
+          </a:prstGeom>
+          <a:noFill/>
+          <a:ln/>
+        </p:spPr>
+        <p:txBody>
+          <a:bodyPr wrap="square" lIns="0" tIns="0" rIns="0" bIns="0" rtlCol="0" anchor="ctr"/>
+          <a:lstStyle/>
+          <a:p>
+            <a:pPr indent="0" marL="0">
+              <a:buNone/>
+            </a:pPr>
+            <a:r>
+              <a:rPr lang="en-US" sz="1150" dirty="0">
+                <a:solidFill>
+                  <a:srgbClr val="3A3F55"/>
+                </a:solidFill>
+                <a:latin typeface="Avenir Next" pitchFamily="34" charset="0"/>
+                <a:ea typeface="Avenir Next" pitchFamily="34" charset="-122"/>
+                <a:cs typeface="Avenir Next" pitchFamily="34" charset="-120"/>
+              </a:rPr>
+              <a:t>Sonnet 5.5 reads every line</a:t>
+            </a:r>
+            <a:endParaRPr lang="en-US" sz="1150" dirty="0"/>
+          </a:p>
+        </p:txBody>
+      </p:sp>
+      <p:sp>
+        <p:nvSpPr>
+          <p:cNvPr id="33" name="Text 24"/>
+          <p:cNvSpPr/>
+          <p:nvPr/>
+        </p:nvSpPr>
+        <p:spPr>
+          <a:xfrm>
+            <a:off x="7406640" y="3246120"/>
+            <a:ext cx="1097280" cy="347472"/>
+          </a:xfrm>
+          <a:prstGeom prst="rect">
+            <a:avLst/>
+          </a:prstGeom>
+          <a:noFill/>
+          <a:ln/>
+        </p:spPr>
+        <p:txBody>
+          <a:bodyPr wrap="square" lIns="0" tIns="0" rIns="0" bIns="0" rtlCol="0" anchor="ctr"/>
+          <a:lstStyle/>
+          <a:p>
+            <a:pPr algn="r" indent="0" marL="0">
+              <a:buNone/>
+            </a:pPr>
+            <a:r>
+              <a:rPr lang="en-US" sz="1600" b="1" dirty="0">
+                <a:solidFill>
+                  <a:srgbClr val="C2410C"/>
+                </a:solidFill>
+                <a:latin typeface="Avenir Next" pitchFamily="34" charset="0"/>
+                <a:ea typeface="Avenir Next" pitchFamily="34" charset="-122"/>
+                <a:cs typeface="Avenir Next" pitchFamily="34" charset="-120"/>
+              </a:rPr>
+              <a:t>≈ $354</a:t>
+            </a:r>
+            <a:endParaRPr lang="en-US" sz="1600" dirty="0"/>
+          </a:p>
+        </p:txBody>
+      </p:sp>
+      <p:sp>
+        <p:nvSpPr>
+          <p:cNvPr id="34" name="Text 25"/>
+          <p:cNvSpPr/>
+          <p:nvPr/>
+        </p:nvSpPr>
+        <p:spPr>
+          <a:xfrm>
+            <a:off x="4937760" y="3703320"/>
+            <a:ext cx="2514600" cy="347472"/>
+          </a:xfrm>
+          <a:prstGeom prst="rect">
+            <a:avLst/>
+          </a:prstGeom>
+          <a:noFill/>
+          <a:ln/>
+        </p:spPr>
+        <p:txBody>
+          <a:bodyPr wrap="square" lIns="0" tIns="0" rIns="0" bIns="0" rtlCol="0" anchor="ctr"/>
+          <a:lstStyle/>
+          <a:p>
+            <a:pPr indent="0" marL="0">
+              <a:buNone/>
+            </a:pPr>
+            <a:r>
+              <a:rPr lang="en-US" sz="1150" dirty="0">
+                <a:solidFill>
+                  <a:srgbClr val="3A3F55"/>
+                </a:solidFill>
+                <a:latin typeface="Avenir Next" pitchFamily="34" charset="0"/>
+                <a:ea typeface="Avenir Next" pitchFamily="34" charset="-122"/>
+                <a:cs typeface="Avenir Next" pitchFamily="34" charset="-120"/>
+              </a:rPr>
+              <a:t>Opus 5.5 reads every line</a:t>
+            </a:r>
+            <a:endParaRPr lang="en-US" sz="1150" dirty="0"/>
+          </a:p>
+        </p:txBody>
+      </p:sp>
+      <p:sp>
+        <p:nvSpPr>
+          <p:cNvPr id="35" name="Text 26"/>
+          <p:cNvSpPr/>
+          <p:nvPr/>
+        </p:nvSpPr>
+        <p:spPr>
+          <a:xfrm>
+            <a:off x="7406640" y="3703320"/>
+            <a:ext cx="1097280" cy="347472"/>
+          </a:xfrm>
+          <a:prstGeom prst="rect">
+            <a:avLst/>
+          </a:prstGeom>
+          <a:noFill/>
+          <a:ln/>
+        </p:spPr>
+        <p:txBody>
+          <a:bodyPr wrap="square" lIns="0" tIns="0" rIns="0" bIns="0" rtlCol="0" anchor="ctr"/>
+          <a:lstStyle/>
+          <a:p>
+            <a:pPr algn="r" indent="0" marL="0">
+              <a:buNone/>
+            </a:pPr>
+            <a:r>
+              <a:rPr lang="en-US" sz="1600" b="1" dirty="0">
+                <a:solidFill>
+                  <a:srgbClr val="C2410C"/>
+                </a:solidFill>
+                <a:latin typeface="Avenir Next" pitchFamily="34" charset="0"/>
+                <a:ea typeface="Avenir Next" pitchFamily="34" charset="-122"/>
+                <a:cs typeface="Avenir Next" pitchFamily="34" charset="-120"/>
+              </a:rPr>
+              <a:t>≈ $708</a:t>
+            </a:r>
+            <a:endParaRPr lang="en-US" sz="1600" dirty="0"/>
+          </a:p>
+        </p:txBody>
+      </p:sp>
+      <p:sp>
+        <p:nvSpPr>
+          <p:cNvPr id="36" name="Text 27"/>
+          <p:cNvSpPr/>
+          <p:nvPr/>
+        </p:nvSpPr>
+        <p:spPr>
+          <a:xfrm>
+            <a:off x="4892040" y="4114800"/>
+            <a:ext cx="3611880" cy="384048"/>
           </a:xfrm>
           <a:prstGeom prst="rect">
             <a:avLst/>
@@ -11120,17 +11270,17 @@
               <a:buNone/>
             </a:pPr>
             <a:r>
-              <a:rPr lang="en-US" sz="1150" dirty="0">
-                <a:solidFill>
-                  <a:srgbClr val="3A3F55"/>
-                </a:solidFill>
-                <a:latin typeface="Avenir Next" pitchFamily="34" charset="0"/>
-                <a:ea typeface="Avenir Next" pitchFamily="34" charset="-122"/>
-                <a:cs typeface="Avenir Next" pitchFamily="34" charset="-120"/>
-              </a:rPr>
-              <a:t>real alerts in the manager's top 10</a:t>
-            </a:r>
-            <a:endParaRPr lang="en-US" sz="1150" dirty="0"/>
+              <a:rPr lang="en-US" sz="850" dirty="0">
+                <a:solidFill>
+                  <a:srgbClr val="6B7386"/>
+                </a:solidFill>
+                <a:latin typeface="Avenir Next" pitchFamily="34" charset="0"/>
+                <a:ea typeface="Avenir Next" pitchFamily="34" charset="-122"/>
+                <a:cs typeface="Avenir Next" pitchFamily="34" charset="-120"/>
+              </a:rPr>
+              <a:t>LLM: ≈ 177 M input tokens (709 MB ÷ ~4 B/token, estimate) × list price; again for every question, and it does not fit one context window.</a:t>
+            </a:r>
+            <a:endParaRPr lang="en-US" sz="850" dirty="0"/>
           </a:p>
         </p:txBody>
       </p:sp>

</xml_diff>

<commit_message>
Judge slide: cost AND time vs an LLM reading BGL, from a measurement (800 KB of BGL = 473,801 tokens → ≈ 440 M tokens; ≈ 48 k tok/s → ≈ 2.5 h; Haiku $220 / Sonnet $880 / Opus $1,760 vs Jev $0.02 · 20 s); README: no demo-script link
Co-Authored-By: Claude Opus 5.5 <noreply@anthropic.com>
</commit_message>
<xml_diff>
--- a/docs/slides/making-sense-of-logs.pptx
+++ b/docs/slides/making-sense-of-logs.pptx
@@ -1538,7 +1538,7 @@
             <a:r>
               <a:rPr lang="en-US" dirty="0"/>
               <a:t>1:15 · 5 · Judge
-"Step two is where it gets cheap. Jev, a small typed-judgment model, runs inside SereneDB and asks each kind of message once: is it a real fault or a routine dump? an attack? whose is it? 1,126 kinds of message in 20 seconds for 2 cents, stored. Having an LLM read BGL instead is about 177 million tokens: roughly 89 dollars on Haiku, 354 on Sonnet, 708 on Opus, and again for every question. And it works: real alerts in the manager's top 10 go from 1 to 5."</a:t>
+"Step two is where it gets cheap. Jev, a small typed-judgment model, runs inside SereneDB and asks each kind of message once: is it a real fault or a routine dump? an attack? whose is it? 1,126 kinds of message in 20 seconds for 2 cents, stored. Having an LLM read BGL instead is about 440 million tokens, measured: about two and a half hours and 220 dollars on Haiku, 880 on Sonnet, 1,760 on Opus, and again for every question. And it works: real alerts in the manager's top 10 go from 1 to 5."</a:t>
             </a:r>
             <a:endParaRPr lang="en-US" dirty="0"/>
           </a:p>
@@ -2480,7 +2480,7 @@
                 <a:ea typeface="Avenir Next" pitchFamily="34" charset="-122"/>
                 <a:cs typeface="Avenir Next" pitchFamily="34" charset="-120"/>
               </a:rPr>
-              <a:t>$0.02</a:t>
+              <a:t>$0.02 · 20 s</a:t>
             </a:r>
             <a:endParaRPr lang="en-US" sz="3600" dirty="0"/>
           </a:p>
@@ -10881,7 +10881,7 @@
         <p:spPr>
           <a:xfrm>
             <a:off x="4892040" y="1965960"/>
-            <a:ext cx="3611880" cy="292608"/>
+            <a:ext cx="2011680" cy="292608"/>
           </a:xfrm>
           <a:prstGeom prst="rect">
             <a:avLst/>
@@ -10905,7 +10905,7 @@
                 <a:ea typeface="Avenir Next" pitchFamily="34" charset="-122"/>
                 <a:cs typeface="Avenir Next" pitchFamily="34" charset="-120"/>
               </a:rPr>
-              <a:t>Cost to judge BGL once</a:t>
+              <a:t>Judge BGL once</a:t>
             </a:r>
             <a:endParaRPr lang="en-US" sz="1250" dirty="0"/>
           </a:p>
@@ -10913,7 +10913,85 @@
       </p:sp>
       <p:sp>
         <p:nvSpPr>
-          <p:cNvPr id="27" name="Shape 18"/>
+          <p:cNvPr id="27" name="Text 18"/>
+          <p:cNvSpPr/>
+          <p:nvPr/>
+        </p:nvSpPr>
+        <p:spPr>
+          <a:xfrm>
+            <a:off x="6903720" y="1965960"/>
+            <a:ext cx="731520" cy="292608"/>
+          </a:xfrm>
+          <a:prstGeom prst="rect">
+            <a:avLst/>
+          </a:prstGeom>
+          <a:noFill/>
+          <a:ln/>
+        </p:spPr>
+        <p:txBody>
+          <a:bodyPr wrap="square" lIns="0" tIns="0" rIns="0" bIns="0" rtlCol="0" anchor="ctr"/>
+          <a:lstStyle/>
+          <a:p>
+            <a:pPr algn="r" indent="0" marL="0">
+              <a:buNone/>
+            </a:pPr>
+            <a:r>
+              <a:rPr lang="en-US" sz="1050" b="1" dirty="0">
+                <a:solidFill>
+                  <a:srgbClr val="6B7386"/>
+                </a:solidFill>
+                <a:latin typeface="Avenir Next" pitchFamily="34" charset="0"/>
+                <a:ea typeface="Avenir Next" pitchFamily="34" charset="-122"/>
+                <a:cs typeface="Avenir Next" pitchFamily="34" charset="-120"/>
+              </a:rPr>
+              <a:t>cost</a:t>
+            </a:r>
+            <a:endParaRPr lang="en-US" sz="1050" dirty="0"/>
+          </a:p>
+        </p:txBody>
+      </p:sp>
+      <p:sp>
+        <p:nvSpPr>
+          <p:cNvPr id="28" name="Text 19"/>
+          <p:cNvSpPr/>
+          <p:nvPr/>
+        </p:nvSpPr>
+        <p:spPr>
+          <a:xfrm>
+            <a:off x="7726680" y="1965960"/>
+            <a:ext cx="777240" cy="292608"/>
+          </a:xfrm>
+          <a:prstGeom prst="rect">
+            <a:avLst/>
+          </a:prstGeom>
+          <a:noFill/>
+          <a:ln/>
+        </p:spPr>
+        <p:txBody>
+          <a:bodyPr wrap="square" lIns="0" tIns="0" rIns="0" bIns="0" rtlCol="0" anchor="ctr"/>
+          <a:lstStyle/>
+          <a:p>
+            <a:pPr algn="r" indent="0" marL="0">
+              <a:buNone/>
+            </a:pPr>
+            <a:r>
+              <a:rPr lang="en-US" sz="1050" b="1" dirty="0">
+                <a:solidFill>
+                  <a:srgbClr val="6B7386"/>
+                </a:solidFill>
+                <a:latin typeface="Avenir Next" pitchFamily="34" charset="0"/>
+                <a:ea typeface="Avenir Next" pitchFamily="34" charset="-122"/>
+                <a:cs typeface="Avenir Next" pitchFamily="34" charset="-120"/>
+              </a:rPr>
+              <a:t>time</a:t>
+            </a:r>
+            <a:endParaRPr lang="en-US" sz="1050" dirty="0"/>
+          </a:p>
+        </p:txBody>
+      </p:sp>
+      <p:sp>
+        <p:nvSpPr>
+          <p:cNvPr id="29" name="Shape 20"/>
           <p:cNvSpPr/>
           <p:nvPr/>
         </p:nvSpPr>
@@ -10935,14 +11013,14 @@
       </p:sp>
       <p:sp>
         <p:nvSpPr>
-          <p:cNvPr id="28" name="Text 19"/>
+          <p:cNvPr id="30" name="Text 21"/>
           <p:cNvSpPr/>
           <p:nvPr/>
         </p:nvSpPr>
         <p:spPr>
           <a:xfrm>
             <a:off x="4937760" y="2331720"/>
-            <a:ext cx="2514600" cy="347472"/>
+            <a:ext cx="2011680" cy="347472"/>
           </a:xfrm>
           <a:prstGeom prst="rect">
             <a:avLst/>
@@ -10958,7 +11036,7 @@
               <a:buNone/>
             </a:pPr>
             <a:r>
-              <a:rPr lang="en-US" sz="1150" b="1" dirty="0">
+              <a:rPr lang="en-US" sz="1100" b="1" dirty="0">
                 <a:solidFill>
                   <a:srgbClr val="3A3F55"/>
                 </a:solidFill>
@@ -10966,22 +11044,22 @@
                 <a:ea typeface="Avenir Next" pitchFamily="34" charset="-122"/>
                 <a:cs typeface="Avenir Next" pitchFamily="34" charset="-120"/>
               </a:rPr>
-              <a:t>Jev, once per kind of message</a:t>
-            </a:r>
-            <a:endParaRPr lang="en-US" sz="1150" dirty="0"/>
-          </a:p>
-        </p:txBody>
-      </p:sp>
-      <p:sp>
-        <p:nvSpPr>
-          <p:cNvPr id="29" name="Text 20"/>
-          <p:cNvSpPr/>
-          <p:nvPr/>
-        </p:nvSpPr>
-        <p:spPr>
-          <a:xfrm>
-            <a:off x="7406640" y="2331720"/>
-            <a:ext cx="1097280" cy="347472"/>
+              <a:t>Jev, per kind of message</a:t>
+            </a:r>
+            <a:endParaRPr lang="en-US" sz="1100" dirty="0"/>
+          </a:p>
+        </p:txBody>
+      </p:sp>
+      <p:sp>
+        <p:nvSpPr>
+          <p:cNvPr id="31" name="Text 22"/>
+          <p:cNvSpPr/>
+          <p:nvPr/>
+        </p:nvSpPr>
+        <p:spPr>
+          <a:xfrm>
+            <a:off x="6812280" y="2331720"/>
+            <a:ext cx="822960" cy="347472"/>
           </a:xfrm>
           <a:prstGeom prst="rect">
             <a:avLst/>
@@ -10997,7 +11075,7 @@
               <a:buNone/>
             </a:pPr>
             <a:r>
-              <a:rPr lang="en-US" sz="1600" b="1" dirty="0">
+              <a:rPr lang="en-US" sz="1500" b="1" dirty="0">
                 <a:solidFill>
                   <a:srgbClr val="6A4BD8"/>
                 </a:solidFill>
@@ -11007,20 +11085,59 @@
               </a:rPr>
               <a:t>$0.02</a:t>
             </a:r>
-            <a:endParaRPr lang="en-US" sz="1600" dirty="0"/>
-          </a:p>
-        </p:txBody>
-      </p:sp>
-      <p:sp>
-        <p:nvSpPr>
-          <p:cNvPr id="30" name="Text 21"/>
+            <a:endParaRPr lang="en-US" sz="1500" dirty="0"/>
+          </a:p>
+        </p:txBody>
+      </p:sp>
+      <p:sp>
+        <p:nvSpPr>
+          <p:cNvPr id="32" name="Text 23"/>
+          <p:cNvSpPr/>
+          <p:nvPr/>
+        </p:nvSpPr>
+        <p:spPr>
+          <a:xfrm>
+            <a:off x="7680960" y="2331720"/>
+            <a:ext cx="822960" cy="347472"/>
+          </a:xfrm>
+          <a:prstGeom prst="rect">
+            <a:avLst/>
+          </a:prstGeom>
+          <a:noFill/>
+          <a:ln/>
+        </p:spPr>
+        <p:txBody>
+          <a:bodyPr wrap="square" lIns="0" tIns="0" rIns="0" bIns="0" rtlCol="0" anchor="ctr"/>
+          <a:lstStyle/>
+          <a:p>
+            <a:pPr algn="r" indent="0" marL="0">
+              <a:buNone/>
+            </a:pPr>
+            <a:r>
+              <a:rPr lang="en-US" sz="1500" b="1" dirty="0">
+                <a:solidFill>
+                  <a:srgbClr val="6A4BD8"/>
+                </a:solidFill>
+                <a:latin typeface="Avenir Next" pitchFamily="34" charset="0"/>
+                <a:ea typeface="Avenir Next" pitchFamily="34" charset="-122"/>
+                <a:cs typeface="Avenir Next" pitchFamily="34" charset="-120"/>
+              </a:rPr>
+              <a:t>20 s</a:t>
+            </a:r>
+            <a:endParaRPr lang="en-US" sz="1500" dirty="0"/>
+          </a:p>
+        </p:txBody>
+      </p:sp>
+      <p:sp>
+        <p:nvSpPr>
+          <p:cNvPr id="33" name="Text 24"/>
           <p:cNvSpPr/>
           <p:nvPr/>
         </p:nvSpPr>
         <p:spPr>
           <a:xfrm>
             <a:off x="4937760" y="2788920"/>
-            <a:ext cx="2514600" cy="347472"/>
+            <a:ext cx="2011680" cy="347472"/>
           </a:xfrm>
           <a:prstGeom prst="rect">
             <a:avLst/>
@@ -11036,7 +11153,7 @@
               <a:buNone/>
             </a:pPr>
             <a:r>
-              <a:rPr lang="en-US" sz="1150" dirty="0">
+              <a:rPr lang="en-US" sz="1100" dirty="0">
                 <a:solidFill>
                   <a:srgbClr val="3A3F55"/>
                 </a:solidFill>
@@ -11044,22 +11161,22 @@
                 <a:ea typeface="Avenir Next" pitchFamily="34" charset="-122"/>
                 <a:cs typeface="Avenir Next" pitchFamily="34" charset="-120"/>
               </a:rPr>
-              <a:t>Haiku 5.5 reads every line</a:t>
-            </a:r>
-            <a:endParaRPr lang="en-US" sz="1150" dirty="0"/>
-          </a:p>
-        </p:txBody>
-      </p:sp>
-      <p:sp>
-        <p:nvSpPr>
-          <p:cNvPr id="31" name="Text 22"/>
-          <p:cNvSpPr/>
-          <p:nvPr/>
-        </p:nvSpPr>
-        <p:spPr>
-          <a:xfrm>
-            <a:off x="7406640" y="2788920"/>
-            <a:ext cx="1097280" cy="347472"/>
+              <a:t>Haiku 5.5 reads all lines</a:t>
+            </a:r>
+            <a:endParaRPr lang="en-US" sz="1100" dirty="0"/>
+          </a:p>
+        </p:txBody>
+      </p:sp>
+      <p:sp>
+        <p:nvSpPr>
+          <p:cNvPr id="34" name="Text 25"/>
+          <p:cNvSpPr/>
+          <p:nvPr/>
+        </p:nvSpPr>
+        <p:spPr>
+          <a:xfrm>
+            <a:off x="6812280" y="2788920"/>
+            <a:ext cx="822960" cy="347472"/>
           </a:xfrm>
           <a:prstGeom prst="rect">
             <a:avLst/>
@@ -11075,7 +11192,7 @@
               <a:buNone/>
             </a:pPr>
             <a:r>
-              <a:rPr lang="en-US" sz="1600" b="1" dirty="0">
+              <a:rPr lang="en-US" sz="1500" b="1" dirty="0">
                 <a:solidFill>
                   <a:srgbClr val="C2410C"/>
                 </a:solidFill>
@@ -11083,22 +11200,61 @@
                 <a:ea typeface="Avenir Next" pitchFamily="34" charset="-122"/>
                 <a:cs typeface="Avenir Next" pitchFamily="34" charset="-120"/>
               </a:rPr>
-              <a:t>≈ $89</a:t>
-            </a:r>
-            <a:endParaRPr lang="en-US" sz="1600" dirty="0"/>
-          </a:p>
-        </p:txBody>
-      </p:sp>
-      <p:sp>
-        <p:nvSpPr>
-          <p:cNvPr id="32" name="Text 23"/>
+              <a:t>$220</a:t>
+            </a:r>
+            <a:endParaRPr lang="en-US" sz="1500" dirty="0"/>
+          </a:p>
+        </p:txBody>
+      </p:sp>
+      <p:sp>
+        <p:nvSpPr>
+          <p:cNvPr id="35" name="Text 26"/>
+          <p:cNvSpPr/>
+          <p:nvPr/>
+        </p:nvSpPr>
+        <p:spPr>
+          <a:xfrm>
+            <a:off x="7680960" y="2788920"/>
+            <a:ext cx="822960" cy="347472"/>
+          </a:xfrm>
+          <a:prstGeom prst="rect">
+            <a:avLst/>
+          </a:prstGeom>
+          <a:noFill/>
+          <a:ln/>
+        </p:spPr>
+        <p:txBody>
+          <a:bodyPr wrap="square" lIns="0" tIns="0" rIns="0" bIns="0" rtlCol="0" anchor="ctr"/>
+          <a:lstStyle/>
+          <a:p>
+            <a:pPr algn="r" indent="0" marL="0">
+              <a:buNone/>
+            </a:pPr>
+            <a:r>
+              <a:rPr lang="en-US" sz="1500" b="1" dirty="0">
+                <a:solidFill>
+                  <a:srgbClr val="C2410C"/>
+                </a:solidFill>
+                <a:latin typeface="Avenir Next" pitchFamily="34" charset="0"/>
+                <a:ea typeface="Avenir Next" pitchFamily="34" charset="-122"/>
+                <a:cs typeface="Avenir Next" pitchFamily="34" charset="-120"/>
+              </a:rPr>
+              <a:t>≈ 2.5 h</a:t>
+            </a:r>
+            <a:endParaRPr lang="en-US" sz="1500" dirty="0"/>
+          </a:p>
+        </p:txBody>
+      </p:sp>
+      <p:sp>
+        <p:nvSpPr>
+          <p:cNvPr id="36" name="Text 27"/>
           <p:cNvSpPr/>
           <p:nvPr/>
         </p:nvSpPr>
         <p:spPr>
           <a:xfrm>
             <a:off x="4937760" y="3246120"/>
-            <a:ext cx="2514600" cy="347472"/>
+            <a:ext cx="2011680" cy="347472"/>
           </a:xfrm>
           <a:prstGeom prst="rect">
             <a:avLst/>
@@ -11114,7 +11270,7 @@
               <a:buNone/>
             </a:pPr>
             <a:r>
-              <a:rPr lang="en-US" sz="1150" dirty="0">
+              <a:rPr lang="en-US" sz="1100" dirty="0">
                 <a:solidFill>
                   <a:srgbClr val="3A3F55"/>
                 </a:solidFill>
@@ -11122,22 +11278,22 @@
                 <a:ea typeface="Avenir Next" pitchFamily="34" charset="-122"/>
                 <a:cs typeface="Avenir Next" pitchFamily="34" charset="-120"/>
               </a:rPr>
-              <a:t>Sonnet 5.5 reads every line</a:t>
-            </a:r>
-            <a:endParaRPr lang="en-US" sz="1150" dirty="0"/>
-          </a:p>
-        </p:txBody>
-      </p:sp>
-      <p:sp>
-        <p:nvSpPr>
-          <p:cNvPr id="33" name="Text 24"/>
-          <p:cNvSpPr/>
-          <p:nvPr/>
-        </p:nvSpPr>
-        <p:spPr>
-          <a:xfrm>
-            <a:off x="7406640" y="3246120"/>
-            <a:ext cx="1097280" cy="347472"/>
+              <a:t>Sonnet 5.5 reads all lines</a:t>
+            </a:r>
+            <a:endParaRPr lang="en-US" sz="1100" dirty="0"/>
+          </a:p>
+        </p:txBody>
+      </p:sp>
+      <p:sp>
+        <p:nvSpPr>
+          <p:cNvPr id="37" name="Text 28"/>
+          <p:cNvSpPr/>
+          <p:nvPr/>
+        </p:nvSpPr>
+        <p:spPr>
+          <a:xfrm>
+            <a:off x="6812280" y="3246120"/>
+            <a:ext cx="822960" cy="347472"/>
           </a:xfrm>
           <a:prstGeom prst="rect">
             <a:avLst/>
@@ -11153,7 +11309,7 @@
               <a:buNone/>
             </a:pPr>
             <a:r>
-              <a:rPr lang="en-US" sz="1600" b="1" dirty="0">
+              <a:rPr lang="en-US" sz="1500" b="1" dirty="0">
                 <a:solidFill>
                   <a:srgbClr val="C2410C"/>
                 </a:solidFill>
@@ -11161,22 +11317,61 @@
                 <a:ea typeface="Avenir Next" pitchFamily="34" charset="-122"/>
                 <a:cs typeface="Avenir Next" pitchFamily="34" charset="-120"/>
               </a:rPr>
-              <a:t>≈ $354</a:t>
-            </a:r>
-            <a:endParaRPr lang="en-US" sz="1600" dirty="0"/>
-          </a:p>
-        </p:txBody>
-      </p:sp>
-      <p:sp>
-        <p:nvSpPr>
-          <p:cNvPr id="34" name="Text 25"/>
+              <a:t>$880</a:t>
+            </a:r>
+            <a:endParaRPr lang="en-US" sz="1500" dirty="0"/>
+          </a:p>
+        </p:txBody>
+      </p:sp>
+      <p:sp>
+        <p:nvSpPr>
+          <p:cNvPr id="38" name="Text 29"/>
+          <p:cNvSpPr/>
+          <p:nvPr/>
+        </p:nvSpPr>
+        <p:spPr>
+          <a:xfrm>
+            <a:off x="7680960" y="3246120"/>
+            <a:ext cx="822960" cy="347472"/>
+          </a:xfrm>
+          <a:prstGeom prst="rect">
+            <a:avLst/>
+          </a:prstGeom>
+          <a:noFill/>
+          <a:ln/>
+        </p:spPr>
+        <p:txBody>
+          <a:bodyPr wrap="square" lIns="0" tIns="0" rIns="0" bIns="0" rtlCol="0" anchor="ctr"/>
+          <a:lstStyle/>
+          <a:p>
+            <a:pPr algn="r" indent="0" marL="0">
+              <a:buNone/>
+            </a:pPr>
+            <a:r>
+              <a:rPr lang="en-US" sz="1500" b="1" dirty="0">
+                <a:solidFill>
+                  <a:srgbClr val="C2410C"/>
+                </a:solidFill>
+                <a:latin typeface="Avenir Next" pitchFamily="34" charset="0"/>
+                <a:ea typeface="Avenir Next" pitchFamily="34" charset="-122"/>
+                <a:cs typeface="Avenir Next" pitchFamily="34" charset="-120"/>
+              </a:rPr>
+              <a:t>≈ 2.5 h</a:t>
+            </a:r>
+            <a:endParaRPr lang="en-US" sz="1500" dirty="0"/>
+          </a:p>
+        </p:txBody>
+      </p:sp>
+      <p:sp>
+        <p:nvSpPr>
+          <p:cNvPr id="39" name="Text 30"/>
           <p:cNvSpPr/>
           <p:nvPr/>
         </p:nvSpPr>
         <p:spPr>
           <a:xfrm>
             <a:off x="4937760" y="3703320"/>
-            <a:ext cx="2514600" cy="347472"/>
+            <a:ext cx="2011680" cy="347472"/>
           </a:xfrm>
           <a:prstGeom prst="rect">
             <a:avLst/>
@@ -11192,7 +11387,7 @@
               <a:buNone/>
             </a:pPr>
             <a:r>
-              <a:rPr lang="en-US" sz="1150" dirty="0">
+              <a:rPr lang="en-US" sz="1100" dirty="0">
                 <a:solidFill>
                   <a:srgbClr val="3A3F55"/>
                 </a:solidFill>
@@ -11200,22 +11395,22 @@
                 <a:ea typeface="Avenir Next" pitchFamily="34" charset="-122"/>
                 <a:cs typeface="Avenir Next" pitchFamily="34" charset="-120"/>
               </a:rPr>
-              <a:t>Opus 5.5 reads every line</a:t>
-            </a:r>
-            <a:endParaRPr lang="en-US" sz="1150" dirty="0"/>
-          </a:p>
-        </p:txBody>
-      </p:sp>
-      <p:sp>
-        <p:nvSpPr>
-          <p:cNvPr id="35" name="Text 26"/>
-          <p:cNvSpPr/>
-          <p:nvPr/>
-        </p:nvSpPr>
-        <p:spPr>
-          <a:xfrm>
-            <a:off x="7406640" y="3703320"/>
-            <a:ext cx="1097280" cy="347472"/>
+              <a:t>Opus 5.5 reads all lines</a:t>
+            </a:r>
+            <a:endParaRPr lang="en-US" sz="1100" dirty="0"/>
+          </a:p>
+        </p:txBody>
+      </p:sp>
+      <p:sp>
+        <p:nvSpPr>
+          <p:cNvPr id="40" name="Text 31"/>
+          <p:cNvSpPr/>
+          <p:nvPr/>
+        </p:nvSpPr>
+        <p:spPr>
+          <a:xfrm>
+            <a:off x="6812280" y="3703320"/>
+            <a:ext cx="822960" cy="347472"/>
           </a:xfrm>
           <a:prstGeom prst="rect">
             <a:avLst/>
@@ -11231,7 +11426,7 @@
               <a:buNone/>
             </a:pPr>
             <a:r>
-              <a:rPr lang="en-US" sz="1600" b="1" dirty="0">
+              <a:rPr lang="en-US" sz="1500" b="1" dirty="0">
                 <a:solidFill>
                   <a:srgbClr val="C2410C"/>
                 </a:solidFill>
@@ -11239,15 +11434,54 @@
                 <a:ea typeface="Avenir Next" pitchFamily="34" charset="-122"/>
                 <a:cs typeface="Avenir Next" pitchFamily="34" charset="-120"/>
               </a:rPr>
-              <a:t>≈ $708</a:t>
-            </a:r>
-            <a:endParaRPr lang="en-US" sz="1600" dirty="0"/>
-          </a:p>
-        </p:txBody>
-      </p:sp>
-      <p:sp>
-        <p:nvSpPr>
-          <p:cNvPr id="36" name="Text 27"/>
+              <a:t>$1,760</a:t>
+            </a:r>
+            <a:endParaRPr lang="en-US" sz="1500" dirty="0"/>
+          </a:p>
+        </p:txBody>
+      </p:sp>
+      <p:sp>
+        <p:nvSpPr>
+          <p:cNvPr id="41" name="Text 32"/>
+          <p:cNvSpPr/>
+          <p:nvPr/>
+        </p:nvSpPr>
+        <p:spPr>
+          <a:xfrm>
+            <a:off x="7680960" y="3703320"/>
+            <a:ext cx="822960" cy="347472"/>
+          </a:xfrm>
+          <a:prstGeom prst="rect">
+            <a:avLst/>
+          </a:prstGeom>
+          <a:noFill/>
+          <a:ln/>
+        </p:spPr>
+        <p:txBody>
+          <a:bodyPr wrap="square" lIns="0" tIns="0" rIns="0" bIns="0" rtlCol="0" anchor="ctr"/>
+          <a:lstStyle/>
+          <a:p>
+            <a:pPr algn="r" indent="0" marL="0">
+              <a:buNone/>
+            </a:pPr>
+            <a:r>
+              <a:rPr lang="en-US" sz="1500" b="1" dirty="0">
+                <a:solidFill>
+                  <a:srgbClr val="C2410C"/>
+                </a:solidFill>
+                <a:latin typeface="Avenir Next" pitchFamily="34" charset="0"/>
+                <a:ea typeface="Avenir Next" pitchFamily="34" charset="-122"/>
+                <a:cs typeface="Avenir Next" pitchFamily="34" charset="-120"/>
+              </a:rPr>
+              <a:t>≈ 2.5 h</a:t>
+            </a:r>
+            <a:endParaRPr lang="en-US" sz="1500" dirty="0"/>
+          </a:p>
+        </p:txBody>
+      </p:sp>
+      <p:sp>
+        <p:nvSpPr>
+          <p:cNvPr id="42" name="Text 33"/>
           <p:cNvSpPr/>
           <p:nvPr/>
         </p:nvSpPr>
@@ -11278,7 +11512,7 @@
                 <a:ea typeface="Avenir Next" pitchFamily="34" charset="-122"/>
                 <a:cs typeface="Avenir Next" pitchFamily="34" charset="-120"/>
               </a:rPr>
-              <a:t>LLM: ≈ 177 M input tokens (709 MB ÷ ~4 B/token, estimate) × list price; again for every question, and it does not fit one context window.</a:t>
+              <a:t>LLM: BGL ≈ 440 M tokens (measured 1.7 B/token), ≥ 440 calls of 1 M; ≈ 48 k tokens/s measured. Again for every question.</a:t>
             </a:r>
             <a:endParaRPr lang="en-US" sz="850" dirty="0"/>
           </a:p>

</xml_diff>